<commit_message>
Update Africa CDC documentation to include "FairBanks Community Health Intelligence Platform (FCHIP)" in titles and subtitles across Word, PDF, and PowerPoint formats. Adjust formatting for improved readability and consistency, ensuring alignment with project branding and messaging guidelines.
</commit_message>
<xml_diff>
--- a/applications/africa-cdc/documents/africa-cdc_ppt.pptx
+++ b/applications/africa-cdc/documents/africa-cdc_ppt.pptx
@@ -3208,7 +3208,7 @@
         <p:spPr>
           <a:xfrm>
             <a:off x="548640" y="4389120"/>
-            <a:ext cx="10972800" cy="594360"/>
+            <a:ext cx="10972800" cy="502920"/>
           </a:xfrm>
           <a:prstGeom prst="rect">
             <a:avLst/>
@@ -3223,7 +3223,7 @@
           <a:p>
             <a:pPr algn="l"/>
             <a:r>
-              <a:rPr sz="2400" b="1" i="0">
+              <a:rPr sz="2200" b="1" i="0">
                 <a:solidFill>
                   <a:srgbClr val="FFFFFF"/>
                 </a:solidFill>
@@ -3242,8 +3242,8 @@
         </p:nvSpPr>
         <p:spPr>
           <a:xfrm>
-            <a:off x="548640" y="5166360"/>
-            <a:ext cx="10972800" cy="365760"/>
+            <a:off x="548640" y="4892040"/>
+            <a:ext cx="10972800" cy="274320"/>
           </a:xfrm>
           <a:prstGeom prst="rect">
             <a:avLst/>
@@ -3258,6 +3258,41 @@
           <a:p>
             <a:pPr algn="l"/>
             <a:r>
+              <a:rPr sz="1300" b="1" i="1">
+                <a:solidFill>
+                  <a:srgbClr val="F2C79B"/>
+                </a:solidFill>
+                <a:latin typeface="Calibri"/>
+              </a:rPr>
+              <a:t>FairBanks Community Health Intelligence Platform (FCHIP)</a:t>
+            </a:r>
+          </a:p>
+        </p:txBody>
+      </p:sp>
+      <p:sp>
+        <p:nvSpPr>
+          <p:cNvPr id="7" name="TextBox 6"/>
+          <p:cNvSpPr txBox="1"/>
+          <p:nvPr/>
+        </p:nvSpPr>
+        <p:spPr>
+          <a:xfrm>
+            <a:off x="548640" y="5257800"/>
+            <a:ext cx="10972800" cy="320040"/>
+          </a:xfrm>
+          <a:prstGeom prst="rect">
+            <a:avLst/>
+          </a:prstGeom>
+          <a:noFill/>
+        </p:spPr>
+        <p:txBody>
+          <a:bodyPr wrap="square">
+            <a:spAutoFit/>
+          </a:bodyPr>
+          <a:lstStyle/>
+          <a:p>
+            <a:pPr algn="l"/>
+            <a:r>
               <a:rPr sz="1400" b="1" i="0">
                 <a:solidFill>
                   <a:srgbClr val="FFFFFF"/>
@@ -3271,7 +3306,7 @@
       </p:sp>
       <p:sp>
         <p:nvSpPr>
-          <p:cNvPr id="7" name="TextBox 6"/>
+          <p:cNvPr id="8" name="TextBox 7"/>
           <p:cNvSpPr txBox="1"/>
           <p:nvPr/>
         </p:nvSpPr>

</xml_diff>

<commit_message>
Enhance PowerPoint generation scripts across multiple applications by introducing balanced text box sizing and vertical alignment for improved readability. Update font sizes for various text elements to ensure consistency and clarity in presentations. Adjust document formatting rules to align with project branding and enhance overall presentation quality.
</commit_message>
<xml_diff>
--- a/applications/africa-cdc/documents/africa-cdc_ppt.pptx
+++ b/applications/africa-cdc/documents/africa-cdc_ppt.pptx
@@ -3186,7 +3186,17 @@
           </a:bodyPr>
           <a:lstStyle/>
           <a:p>
-            <a:pPr algn="l"/>
+            <a:pPr algn="l">
+              <a:lnSpc>
+                <a:spcPct val="115000"/>
+              </a:lnSpc>
+              <a:spcBef>
+                <a:spcPts val="0"/>
+              </a:spcBef>
+              <a:spcAft>
+                <a:spcPts val="200"/>
+              </a:spcAft>
+            </a:pPr>
             <a:r>
               <a:rPr sz="1300" b="1" i="0">
                 <a:solidFill>
@@ -3221,7 +3231,17 @@
           </a:bodyPr>
           <a:lstStyle/>
           <a:p>
-            <a:pPr algn="l"/>
+            <a:pPr algn="l">
+              <a:lnSpc>
+                <a:spcPct val="115000"/>
+              </a:lnSpc>
+              <a:spcBef>
+                <a:spcPts val="0"/>
+              </a:spcBef>
+              <a:spcAft>
+                <a:spcPts val="200"/>
+              </a:spcAft>
+            </a:pPr>
             <a:r>
               <a:rPr sz="2200" b="1" i="0">
                 <a:solidFill>
@@ -3256,7 +3276,17 @@
           </a:bodyPr>
           <a:lstStyle/>
           <a:p>
-            <a:pPr algn="l"/>
+            <a:pPr algn="l">
+              <a:lnSpc>
+                <a:spcPct val="115000"/>
+              </a:lnSpc>
+              <a:spcBef>
+                <a:spcPts val="0"/>
+              </a:spcBef>
+              <a:spcAft>
+                <a:spcPts val="200"/>
+              </a:spcAft>
+            </a:pPr>
             <a:r>
               <a:rPr sz="1300" b="1" i="1">
                 <a:solidFill>
@@ -3291,7 +3321,17 @@
           </a:bodyPr>
           <a:lstStyle/>
           <a:p>
-            <a:pPr algn="l"/>
+            <a:pPr algn="l">
+              <a:lnSpc>
+                <a:spcPct val="115000"/>
+              </a:lnSpc>
+              <a:spcBef>
+                <a:spcPts val="0"/>
+              </a:spcBef>
+              <a:spcAft>
+                <a:spcPts val="200"/>
+              </a:spcAft>
+            </a:pPr>
             <a:r>
               <a:rPr sz="1400" b="1" i="0">
                 <a:solidFill>
@@ -3326,7 +3366,17 @@
           </a:bodyPr>
           <a:lstStyle/>
           <a:p>
-            <a:pPr algn="l"/>
+            <a:pPr algn="l">
+              <a:lnSpc>
+                <a:spcPct val="115000"/>
+              </a:lnSpc>
+              <a:spcBef>
+                <a:spcPts val="0"/>
+              </a:spcBef>
+              <a:spcAft>
+                <a:spcPts val="200"/>
+              </a:spcAft>
+            </a:pPr>
             <a:r>
               <a:rPr sz="1200" b="0" i="0">
                 <a:solidFill>
@@ -3446,7 +3496,17 @@
           </a:bodyPr>
           <a:lstStyle/>
           <a:p>
-            <a:pPr algn="l"/>
+            <a:pPr algn="l">
+              <a:lnSpc>
+                <a:spcPct val="115000"/>
+              </a:lnSpc>
+              <a:spcBef>
+                <a:spcPts val="0"/>
+              </a:spcBef>
+              <a:spcAft>
+                <a:spcPts val="200"/>
+              </a:spcAft>
+            </a:pPr>
             <a:r>
               <a:rPr sz="2400" b="1" i="0">
                 <a:solidFill>
@@ -3481,7 +3541,17 @@
           </a:bodyPr>
           <a:lstStyle/>
           <a:p>
-            <a:pPr algn="l"/>
+            <a:pPr algn="l">
+              <a:lnSpc>
+                <a:spcPct val="115000"/>
+              </a:lnSpc>
+              <a:spcBef>
+                <a:spcPts val="0"/>
+              </a:spcBef>
+              <a:spcAft>
+                <a:spcPts val="200"/>
+              </a:spcAft>
+            </a:pPr>
             <a:r>
               <a:rPr sz="1400" b="1" i="0">
                 <a:solidFill>
@@ -3516,7 +3586,17 @@
           </a:bodyPr>
           <a:lstStyle/>
           <a:p>
-            <a:pPr algn="l"/>
+            <a:pPr algn="l">
+              <a:lnSpc>
+                <a:spcPct val="115000"/>
+              </a:lnSpc>
+              <a:spcBef>
+                <a:spcPts val="0"/>
+              </a:spcBef>
+              <a:spcAft>
+                <a:spcPts val="200"/>
+              </a:spcAft>
+            </a:pPr>
             <a:r>
               <a:rPr sz="1200" b="0" i="0">
                 <a:solidFill>
@@ -3655,7 +3735,17 @@
           </a:bodyPr>
           <a:lstStyle/>
           <a:p>
-            <a:pPr algn="l"/>
+            <a:pPr algn="l">
+              <a:lnSpc>
+                <a:spcPct val="115000"/>
+              </a:lnSpc>
+              <a:spcBef>
+                <a:spcPts val="0"/>
+              </a:spcBef>
+              <a:spcAft>
+                <a:spcPts val="200"/>
+              </a:spcAft>
+            </a:pPr>
             <a:r>
               <a:rPr sz="1100" b="1" i="0">
                 <a:solidFill>
@@ -3690,7 +3780,17 @@
           </a:bodyPr>
           <a:lstStyle/>
           <a:p>
-            <a:pPr algn="l"/>
+            <a:pPr algn="l">
+              <a:lnSpc>
+                <a:spcPct val="115000"/>
+              </a:lnSpc>
+              <a:spcBef>
+                <a:spcPts val="0"/>
+              </a:spcBef>
+              <a:spcAft>
+                <a:spcPts val="200"/>
+              </a:spcAft>
+            </a:pPr>
             <a:r>
               <a:rPr sz="2400" b="1" i="0">
                 <a:solidFill>
@@ -3725,19 +3825,113 @@
           </a:bodyPr>
           <a:lstStyle/>
           <a:p>
-            <a:pPr algn="l"/>
-            <a:r>
-              <a:rPr sz="1700" b="0" i="0">
+            <a:pPr algn="l">
+              <a:lnSpc>
+                <a:spcPct val="128000"/>
+              </a:lnSpc>
+              <a:spcBef>
+                <a:spcPts val="0"/>
+              </a:spcBef>
+              <a:spcAft>
+                <a:spcPts val="1400"/>
+              </a:spcAft>
+            </a:pPr>
+            <a:r>
+              <a:rPr sz="2600" b="0" i="0">
                 <a:solidFill>
                   <a:srgbClr val="1E2F38"/>
                 </a:solidFill>
                 <a:latin typeface="Calibri"/>
               </a:rPr>
-              <a:t>• 3 months core training in Addis Ababa
-• 21 months field placement with employer support
-• Epidemiology or Public Health Informatics track
-• Stipend, travel, insurance, hardware, software
-• African Union citizens under 35 in public health</a:t>
+              <a:t>• 3 months core training in Addis Ababa</a:t>
+            </a:r>
+          </a:p>
+          <a:p>
+            <a:pPr algn="l">
+              <a:lnSpc>
+                <a:spcPct val="128000"/>
+              </a:lnSpc>
+              <a:spcBef>
+                <a:spcPts val="0"/>
+              </a:spcBef>
+              <a:spcAft>
+                <a:spcPts val="1400"/>
+              </a:spcAft>
+            </a:pPr>
+            <a:r>
+              <a:rPr sz="2600" b="0" i="0">
+                <a:solidFill>
+                  <a:srgbClr val="1E2F38"/>
+                </a:solidFill>
+                <a:latin typeface="Calibri"/>
+              </a:rPr>
+              <a:t>• 21 months field placement with employer support</a:t>
+            </a:r>
+          </a:p>
+          <a:p>
+            <a:pPr algn="l">
+              <a:lnSpc>
+                <a:spcPct val="128000"/>
+              </a:lnSpc>
+              <a:spcBef>
+                <a:spcPts val="0"/>
+              </a:spcBef>
+              <a:spcAft>
+                <a:spcPts val="1400"/>
+              </a:spcAft>
+            </a:pPr>
+            <a:r>
+              <a:rPr sz="2600" b="0" i="0">
+                <a:solidFill>
+                  <a:srgbClr val="1E2F38"/>
+                </a:solidFill>
+                <a:latin typeface="Calibri"/>
+              </a:rPr>
+              <a:t>• Epidemiology or Public Health Informatics track</a:t>
+            </a:r>
+          </a:p>
+          <a:p>
+            <a:pPr algn="l">
+              <a:lnSpc>
+                <a:spcPct val="128000"/>
+              </a:lnSpc>
+              <a:spcBef>
+                <a:spcPts val="0"/>
+              </a:spcBef>
+              <a:spcAft>
+                <a:spcPts val="1400"/>
+              </a:spcAft>
+            </a:pPr>
+            <a:r>
+              <a:rPr sz="2600" b="0" i="0">
+                <a:solidFill>
+                  <a:srgbClr val="1E2F38"/>
+                </a:solidFill>
+                <a:latin typeface="Calibri"/>
+              </a:rPr>
+              <a:t>• Stipend, travel, insurance, hardware, software</a:t>
+            </a:r>
+          </a:p>
+          <a:p>
+            <a:pPr algn="l">
+              <a:lnSpc>
+                <a:spcPct val="128000"/>
+              </a:lnSpc>
+              <a:spcBef>
+                <a:spcPts val="0"/>
+              </a:spcBef>
+              <a:spcAft>
+                <a:spcPts val="200"/>
+              </a:spcAft>
+            </a:pPr>
+            <a:r>
+              <a:rPr sz="2600" b="0" i="0">
+                <a:solidFill>
+                  <a:srgbClr val="1E2F38"/>
+                </a:solidFill>
+                <a:latin typeface="Calibri"/>
+              </a:rPr>
+              <a:t>• African Union citizens under 35 in public health</a:t>
             </a:r>
           </a:p>
         </p:txBody>
@@ -3831,7 +4025,17 @@
           </a:bodyPr>
           <a:lstStyle/>
           <a:p>
-            <a:pPr algn="l"/>
+            <a:pPr algn="l">
+              <a:lnSpc>
+                <a:spcPct val="115000"/>
+              </a:lnSpc>
+              <a:spcBef>
+                <a:spcPts val="0"/>
+              </a:spcBef>
+              <a:spcAft>
+                <a:spcPts val="200"/>
+              </a:spcAft>
+            </a:pPr>
             <a:r>
               <a:rPr sz="900" b="0" i="0">
                 <a:solidFill>
@@ -3866,7 +4070,17 @@
           </a:bodyPr>
           <a:lstStyle/>
           <a:p>
-            <a:pPr algn="r"/>
+            <a:pPr algn="r">
+              <a:lnSpc>
+                <a:spcPct val="115000"/>
+              </a:lnSpc>
+              <a:spcBef>
+                <a:spcPts val="0"/>
+              </a:spcBef>
+              <a:spcAft>
+                <a:spcPts val="200"/>
+              </a:spcAft>
+            </a:pPr>
             <a:r>
               <a:rPr sz="900" b="0" i="0">
                 <a:solidFill>
@@ -4005,7 +4219,17 @@
           </a:bodyPr>
           <a:lstStyle/>
           <a:p>
-            <a:pPr algn="l"/>
+            <a:pPr algn="l">
+              <a:lnSpc>
+                <a:spcPct val="115000"/>
+              </a:lnSpc>
+              <a:spcBef>
+                <a:spcPts val="0"/>
+              </a:spcBef>
+              <a:spcAft>
+                <a:spcPts val="200"/>
+              </a:spcAft>
+            </a:pPr>
             <a:r>
               <a:rPr sz="1100" b="1" i="0">
                 <a:solidFill>
@@ -4040,7 +4264,17 @@
           </a:bodyPr>
           <a:lstStyle/>
           <a:p>
-            <a:pPr algn="l"/>
+            <a:pPr algn="l">
+              <a:lnSpc>
+                <a:spcPct val="115000"/>
+              </a:lnSpc>
+              <a:spcBef>
+                <a:spcPts val="0"/>
+              </a:spcBef>
+              <a:spcAft>
+                <a:spcPts val="200"/>
+              </a:spcAft>
+            </a:pPr>
             <a:r>
               <a:rPr sz="2400" b="1" i="0">
                 <a:solidFill>
@@ -4099,16 +4333,47 @@
           </a:bodyPr>
           <a:lstStyle/>
           <a:p>
-            <a:pPr algn="l"/>
-            <a:r>
-              <a:rPr sz="1600" b="0" i="0">
+            <a:pPr algn="l">
+              <a:lnSpc>
+                <a:spcPct val="128000"/>
+              </a:lnSpc>
+              <a:spcBef>
+                <a:spcPts val="0"/>
+              </a:spcBef>
+              <a:spcAft>
+                <a:spcPts val="1400"/>
+              </a:spcAft>
+            </a:pPr>
+            <a:r>
+              <a:rPr sz="2600" b="0" i="0">
                 <a:solidFill>
                   <a:srgbClr val="3A4A54"/>
                 </a:solidFill>
                 <a:latin typeface="Calibri"/>
               </a:rPr>
-              <a:t>Community signals from CHWs only become action with investigation discipline, trend analysis, and informatics pipelines.
-FairBanks lives inside primary care — the right place to grow Africa's epidemic readiness.</a:t>
+              <a:t>Community signals from CHWs only become action with investigation discipline, trend analysis, and informatics pipelines.</a:t>
+            </a:r>
+          </a:p>
+          <a:p>
+            <a:pPr algn="l">
+              <a:lnSpc>
+                <a:spcPct val="128000"/>
+              </a:lnSpc>
+              <a:spcBef>
+                <a:spcPts val="0"/>
+              </a:spcBef>
+              <a:spcAft>
+                <a:spcPts val="200"/>
+              </a:spcAft>
+            </a:pPr>
+            <a:r>
+              <a:rPr sz="2600" b="0" i="0">
+                <a:solidFill>
+                  <a:srgbClr val="3A4A54"/>
+                </a:solidFill>
+                <a:latin typeface="Calibri"/>
+              </a:rPr>
+              <a:t>FairBanks lives inside primary care — the right place to grow Africa's epidemic readiness.</a:t>
             </a:r>
           </a:p>
         </p:txBody>
@@ -4178,7 +4443,17 @@
           </a:bodyPr>
           <a:lstStyle/>
           <a:p>
-            <a:pPr algn="l"/>
+            <a:pPr algn="l">
+              <a:lnSpc>
+                <a:spcPct val="115000"/>
+              </a:lnSpc>
+              <a:spcBef>
+                <a:spcPts val="0"/>
+              </a:spcBef>
+              <a:spcAft>
+                <a:spcPts val="200"/>
+              </a:spcAft>
+            </a:pPr>
             <a:r>
               <a:rPr sz="900" b="0" i="0">
                 <a:solidFill>
@@ -4213,7 +4488,17 @@
           </a:bodyPr>
           <a:lstStyle/>
           <a:p>
-            <a:pPr algn="r"/>
+            <a:pPr algn="r">
+              <a:lnSpc>
+                <a:spcPct val="115000"/>
+              </a:lnSpc>
+              <a:spcBef>
+                <a:spcPts val="0"/>
+              </a:spcBef>
+              <a:spcAft>
+                <a:spcPts val="200"/>
+              </a:spcAft>
+            </a:pPr>
             <a:r>
               <a:rPr sz="900" b="0" i="0">
                 <a:solidFill>
@@ -4352,7 +4637,17 @@
           </a:bodyPr>
           <a:lstStyle/>
           <a:p>
-            <a:pPr algn="l"/>
+            <a:pPr algn="l">
+              <a:lnSpc>
+                <a:spcPct val="115000"/>
+              </a:lnSpc>
+              <a:spcBef>
+                <a:spcPts val="0"/>
+              </a:spcBef>
+              <a:spcAft>
+                <a:spcPts val="200"/>
+              </a:spcAft>
+            </a:pPr>
             <a:r>
               <a:rPr sz="1100" b="1" i="0">
                 <a:solidFill>
@@ -4387,7 +4682,17 @@
           </a:bodyPr>
           <a:lstStyle/>
           <a:p>
-            <a:pPr algn="l"/>
+            <a:pPr algn="l">
+              <a:lnSpc>
+                <a:spcPct val="115000"/>
+              </a:lnSpc>
+              <a:spcBef>
+                <a:spcPts val="0"/>
+              </a:spcBef>
+              <a:spcAft>
+                <a:spcPts val="200"/>
+              </a:spcAft>
+            </a:pPr>
             <a:r>
               <a:rPr sz="2400" b="1" i="0">
                 <a:solidFill>
@@ -4446,18 +4751,91 @@
           </a:bodyPr>
           <a:lstStyle/>
           <a:p>
-            <a:pPr algn="l"/>
-            <a:r>
-              <a:rPr sz="1500" b="0" i="0">
+            <a:pPr algn="l">
+              <a:lnSpc>
+                <a:spcPct val="128000"/>
+              </a:lnSpc>
+              <a:spcBef>
+                <a:spcPts val="0"/>
+              </a:spcBef>
+              <a:spcAft>
+                <a:spcPts val="1400"/>
+              </a:spcAft>
+            </a:pPr>
+            <a:r>
+              <a:rPr sz="2600" b="0" i="0">
                 <a:solidFill>
                   <a:srgbClr val="3A4A54"/>
                 </a:solidFill>
                 <a:latin typeface="Calibri"/>
               </a:rPr>
-              <a:t>Standardise outbreak workflows
-Improve CHW data quality
-Cascade training to supervisors
-Validate FCHIP alerts with surveillance methods</a:t>
+              <a:t>Standardise outbreak workflows</a:t>
+            </a:r>
+          </a:p>
+          <a:p>
+            <a:pPr algn="l">
+              <a:lnSpc>
+                <a:spcPct val="128000"/>
+              </a:lnSpc>
+              <a:spcBef>
+                <a:spcPts val="0"/>
+              </a:spcBef>
+              <a:spcAft>
+                <a:spcPts val="1400"/>
+              </a:spcAft>
+            </a:pPr>
+            <a:r>
+              <a:rPr sz="2600" b="0" i="0">
+                <a:solidFill>
+                  <a:srgbClr val="3A4A54"/>
+                </a:solidFill>
+                <a:latin typeface="Calibri"/>
+              </a:rPr>
+              <a:t>Improve CHW data quality</a:t>
+            </a:r>
+          </a:p>
+          <a:p>
+            <a:pPr algn="l">
+              <a:lnSpc>
+                <a:spcPct val="128000"/>
+              </a:lnSpc>
+              <a:spcBef>
+                <a:spcPts val="0"/>
+              </a:spcBef>
+              <a:spcAft>
+                <a:spcPts val="1400"/>
+              </a:spcAft>
+            </a:pPr>
+            <a:r>
+              <a:rPr sz="2600" b="0" i="0">
+                <a:solidFill>
+                  <a:srgbClr val="3A4A54"/>
+                </a:solidFill>
+                <a:latin typeface="Calibri"/>
+              </a:rPr>
+              <a:t>Cascade training to supervisors</a:t>
+            </a:r>
+          </a:p>
+          <a:p>
+            <a:pPr algn="l">
+              <a:lnSpc>
+                <a:spcPct val="128000"/>
+              </a:lnSpc>
+              <a:spcBef>
+                <a:spcPts val="0"/>
+              </a:spcBef>
+              <a:spcAft>
+                <a:spcPts val="200"/>
+              </a:spcAft>
+            </a:pPr>
+            <a:r>
+              <a:rPr sz="2600" b="0" i="0">
+                <a:solidFill>
+                  <a:srgbClr val="3A4A54"/>
+                </a:solidFill>
+                <a:latin typeface="Calibri"/>
+              </a:rPr>
+              <a:t>Validate FCHIP alerts with surveillance methods</a:t>
             </a:r>
           </a:p>
         </p:txBody>
@@ -4527,7 +4905,17 @@
           </a:bodyPr>
           <a:lstStyle/>
           <a:p>
-            <a:pPr algn="l"/>
+            <a:pPr algn="l">
+              <a:lnSpc>
+                <a:spcPct val="115000"/>
+              </a:lnSpc>
+              <a:spcBef>
+                <a:spcPts val="0"/>
+              </a:spcBef>
+              <a:spcAft>
+                <a:spcPts val="200"/>
+              </a:spcAft>
+            </a:pPr>
             <a:r>
               <a:rPr sz="900" b="0" i="0">
                 <a:solidFill>
@@ -4562,7 +4950,17 @@
           </a:bodyPr>
           <a:lstStyle/>
           <a:p>
-            <a:pPr algn="r"/>
+            <a:pPr algn="r">
+              <a:lnSpc>
+                <a:spcPct val="115000"/>
+              </a:lnSpc>
+              <a:spcBef>
+                <a:spcPts val="0"/>
+              </a:spcBef>
+              <a:spcAft>
+                <a:spcPts val="200"/>
+              </a:spcAft>
+            </a:pPr>
             <a:r>
               <a:rPr sz="900" b="0" i="0">
                 <a:solidFill>
@@ -4701,7 +5099,17 @@
           </a:bodyPr>
           <a:lstStyle/>
           <a:p>
-            <a:pPr algn="l"/>
+            <a:pPr algn="l">
+              <a:lnSpc>
+                <a:spcPct val="115000"/>
+              </a:lnSpc>
+              <a:spcBef>
+                <a:spcPts val="0"/>
+              </a:spcBef>
+              <a:spcAft>
+                <a:spcPts val="200"/>
+              </a:spcAft>
+            </a:pPr>
             <a:r>
               <a:rPr sz="1100" b="1" i="0">
                 <a:solidFill>
@@ -4736,7 +5144,17 @@
           </a:bodyPr>
           <a:lstStyle/>
           <a:p>
-            <a:pPr algn="l"/>
+            <a:pPr algn="l">
+              <a:lnSpc>
+                <a:spcPct val="115000"/>
+              </a:lnSpc>
+              <a:spcBef>
+                <a:spcPts val="0"/>
+              </a:spcBef>
+              <a:spcAft>
+                <a:spcPts val="200"/>
+              </a:spcAft>
+            </a:pPr>
             <a:r>
               <a:rPr sz="2400" b="1" i="0">
                 <a:solidFill>
@@ -4816,7 +5234,17 @@
           </a:bodyPr>
           <a:lstStyle/>
           <a:p>
-            <a:pPr algn="l"/>
+            <a:pPr algn="l">
+              <a:lnSpc>
+                <a:spcPct val="115000"/>
+              </a:lnSpc>
+              <a:spcBef>
+                <a:spcPts val="0"/>
+              </a:spcBef>
+              <a:spcAft>
+                <a:spcPts val="200"/>
+              </a:spcAft>
+            </a:pPr>
             <a:r>
               <a:rPr sz="1600" b="1" i="0">
                 <a:solidFill>
@@ -4851,9 +5279,19 @@
           </a:bodyPr>
           <a:lstStyle/>
           <a:p>
-            <a:pPr algn="l"/>
-            <a:r>
-              <a:rPr sz="1400" b="0" i="0">
+            <a:pPr algn="l">
+              <a:lnSpc>
+                <a:spcPct val="128000"/>
+              </a:lnSpc>
+              <a:spcBef>
+                <a:spcPts val="0"/>
+              </a:spcBef>
+              <a:spcAft>
+                <a:spcPts val="200"/>
+              </a:spcAft>
+            </a:pPr>
+            <a:r>
+              <a:rPr sz="2600" b="0" i="0">
                 <a:solidFill>
                   <a:srgbClr val="3A4A54"/>
                 </a:solidFill>
@@ -4931,7 +5369,17 @@
           </a:bodyPr>
           <a:lstStyle/>
           <a:p>
-            <a:pPr algn="l"/>
+            <a:pPr algn="l">
+              <a:lnSpc>
+                <a:spcPct val="115000"/>
+              </a:lnSpc>
+              <a:spcBef>
+                <a:spcPts val="0"/>
+              </a:spcBef>
+              <a:spcAft>
+                <a:spcPts val="200"/>
+              </a:spcAft>
+            </a:pPr>
             <a:r>
               <a:rPr sz="1600" b="1" i="0">
                 <a:solidFill>
@@ -4966,9 +5414,19 @@
           </a:bodyPr>
           <a:lstStyle/>
           <a:p>
-            <a:pPr algn="l"/>
-            <a:r>
-              <a:rPr sz="1400" b="0" i="0">
+            <a:pPr algn="l">
+              <a:lnSpc>
+                <a:spcPct val="128000"/>
+              </a:lnSpc>
+              <a:spcBef>
+                <a:spcPts val="0"/>
+              </a:spcBef>
+              <a:spcAft>
+                <a:spcPts val="200"/>
+              </a:spcAft>
+            </a:pPr>
+            <a:r>
+              <a:rPr sz="2500" b="0" i="0">
                 <a:solidFill>
                   <a:srgbClr val="3A4A54"/>
                 </a:solidFill>
@@ -5044,7 +5502,17 @@
           </a:bodyPr>
           <a:lstStyle/>
           <a:p>
-            <a:pPr algn="l"/>
+            <a:pPr algn="l">
+              <a:lnSpc>
+                <a:spcPct val="115000"/>
+              </a:lnSpc>
+              <a:spcBef>
+                <a:spcPts val="0"/>
+              </a:spcBef>
+              <a:spcAft>
+                <a:spcPts val="200"/>
+              </a:spcAft>
+            </a:pPr>
             <a:r>
               <a:rPr sz="900" b="0" i="0">
                 <a:solidFill>
@@ -5079,7 +5547,17 @@
           </a:bodyPr>
           <a:lstStyle/>
           <a:p>
-            <a:pPr algn="r"/>
+            <a:pPr algn="r">
+              <a:lnSpc>
+                <a:spcPct val="115000"/>
+              </a:lnSpc>
+              <a:spcBef>
+                <a:spcPts val="0"/>
+              </a:spcBef>
+              <a:spcAft>
+                <a:spcPts val="200"/>
+              </a:spcAft>
+            </a:pPr>
             <a:r>
               <a:rPr sz="900" b="0" i="0">
                 <a:solidFill>
@@ -5218,7 +5696,17 @@
           </a:bodyPr>
           <a:lstStyle/>
           <a:p>
-            <a:pPr algn="l"/>
+            <a:pPr algn="l">
+              <a:lnSpc>
+                <a:spcPct val="115000"/>
+              </a:lnSpc>
+              <a:spcBef>
+                <a:spcPts val="0"/>
+              </a:spcBef>
+              <a:spcAft>
+                <a:spcPts val="200"/>
+              </a:spcAft>
+            </a:pPr>
             <a:r>
               <a:rPr sz="1100" b="1" i="0">
                 <a:solidFill>
@@ -5253,7 +5741,17 @@
           </a:bodyPr>
           <a:lstStyle/>
           <a:p>
-            <a:pPr algn="l"/>
+            <a:pPr algn="l">
+              <a:lnSpc>
+                <a:spcPct val="115000"/>
+              </a:lnSpc>
+              <a:spcBef>
+                <a:spcPts val="0"/>
+              </a:spcBef>
+              <a:spcAft>
+                <a:spcPts val="200"/>
+              </a:spcAft>
+            </a:pPr>
             <a:r>
               <a:rPr sz="2400" b="1" i="0">
                 <a:solidFill>
@@ -5376,9 +5874,19 @@
           </a:bodyPr>
           <a:lstStyle/>
           <a:p>
-            <a:pPr algn="l"/>
-            <a:r>
-              <a:rPr sz="1400" b="0" i="0">
+            <a:pPr algn="l">
+              <a:lnSpc>
+                <a:spcPct val="115000"/>
+              </a:lnSpc>
+              <a:spcBef>
+                <a:spcPts val="0"/>
+              </a:spcBef>
+              <a:spcAft>
+                <a:spcPts val="200"/>
+              </a:spcAft>
+            </a:pPr>
+            <a:r>
+              <a:rPr sz="1800" b="0" i="0">
                 <a:solidFill>
                   <a:srgbClr val="1E2F38"/>
                 </a:solidFill>
@@ -5499,9 +6007,19 @@
           </a:bodyPr>
           <a:lstStyle/>
           <a:p>
-            <a:pPr algn="l"/>
-            <a:r>
-              <a:rPr sz="1400" b="0" i="0">
+            <a:pPr algn="l">
+              <a:lnSpc>
+                <a:spcPct val="115000"/>
+              </a:lnSpc>
+              <a:spcBef>
+                <a:spcPts val="0"/>
+              </a:spcBef>
+              <a:spcAft>
+                <a:spcPts val="200"/>
+              </a:spcAft>
+            </a:pPr>
+            <a:r>
+              <a:rPr sz="1800" b="0" i="0">
                 <a:solidFill>
                   <a:srgbClr val="1E2F38"/>
                 </a:solidFill>
@@ -5622,9 +6140,19 @@
           </a:bodyPr>
           <a:lstStyle/>
           <a:p>
-            <a:pPr algn="l"/>
-            <a:r>
-              <a:rPr sz="1400" b="0" i="0">
+            <a:pPr algn="l">
+              <a:lnSpc>
+                <a:spcPct val="115000"/>
+              </a:lnSpc>
+              <a:spcBef>
+                <a:spcPts val="0"/>
+              </a:spcBef>
+              <a:spcAft>
+                <a:spcPts val="200"/>
+              </a:spcAft>
+            </a:pPr>
+            <a:r>
+              <a:rPr sz="1800" b="0" i="0">
                 <a:solidFill>
                   <a:srgbClr val="1E2F38"/>
                 </a:solidFill>
@@ -5700,7 +6228,17 @@
           </a:bodyPr>
           <a:lstStyle/>
           <a:p>
-            <a:pPr algn="l"/>
+            <a:pPr algn="l">
+              <a:lnSpc>
+                <a:spcPct val="115000"/>
+              </a:lnSpc>
+              <a:spcBef>
+                <a:spcPts val="0"/>
+              </a:spcBef>
+              <a:spcAft>
+                <a:spcPts val="200"/>
+              </a:spcAft>
+            </a:pPr>
             <a:r>
               <a:rPr sz="900" b="0" i="0">
                 <a:solidFill>
@@ -5735,7 +6273,17 @@
           </a:bodyPr>
           <a:lstStyle/>
           <a:p>
-            <a:pPr algn="r"/>
+            <a:pPr algn="r">
+              <a:lnSpc>
+                <a:spcPct val="115000"/>
+              </a:lnSpc>
+              <a:spcBef>
+                <a:spcPts val="0"/>
+              </a:spcBef>
+              <a:spcAft>
+                <a:spcPts val="200"/>
+              </a:spcAft>
+            </a:pPr>
             <a:r>
               <a:rPr sz="900" b="0" i="0">
                 <a:solidFill>
@@ -5874,7 +6422,17 @@
           </a:bodyPr>
           <a:lstStyle/>
           <a:p>
-            <a:pPr algn="l"/>
+            <a:pPr algn="l">
+              <a:lnSpc>
+                <a:spcPct val="115000"/>
+              </a:lnSpc>
+              <a:spcBef>
+                <a:spcPts val="0"/>
+              </a:spcBef>
+              <a:spcAft>
+                <a:spcPts val="200"/>
+              </a:spcAft>
+            </a:pPr>
             <a:r>
               <a:rPr sz="1100" b="1" i="0">
                 <a:solidFill>
@@ -5909,7 +6467,17 @@
           </a:bodyPr>
           <a:lstStyle/>
           <a:p>
-            <a:pPr algn="l"/>
+            <a:pPr algn="l">
+              <a:lnSpc>
+                <a:spcPct val="115000"/>
+              </a:lnSpc>
+              <a:spcBef>
+                <a:spcPts val="0"/>
+              </a:spcBef>
+              <a:spcAft>
+                <a:spcPts val="200"/>
+              </a:spcAft>
+            </a:pPr>
             <a:r>
               <a:rPr sz="2400" b="1" i="0">
                 <a:solidFill>
@@ -5989,7 +6557,17 @@
           </a:bodyPr>
           <a:lstStyle/>
           <a:p>
-            <a:pPr algn="l"/>
+            <a:pPr algn="l">
+              <a:lnSpc>
+                <a:spcPct val="115000"/>
+              </a:lnSpc>
+              <a:spcBef>
+                <a:spcPts val="0"/>
+              </a:spcBef>
+              <a:spcAft>
+                <a:spcPts val="200"/>
+              </a:spcAft>
+            </a:pPr>
             <a:r>
               <a:rPr sz="1400" b="1" i="0">
                 <a:solidFill>
@@ -6024,7 +6602,17 @@
           </a:bodyPr>
           <a:lstStyle/>
           <a:p>
-            <a:pPr algn="l"/>
+            <a:pPr algn="l">
+              <a:lnSpc>
+                <a:spcPct val="115000"/>
+              </a:lnSpc>
+              <a:spcBef>
+                <a:spcPts val="0"/>
+              </a:spcBef>
+              <a:spcAft>
+                <a:spcPts val="200"/>
+              </a:spcAft>
+            </a:pPr>
             <a:r>
               <a:rPr sz="1300" b="0" i="0">
                 <a:solidFill>
@@ -6104,7 +6692,17 @@
           </a:bodyPr>
           <a:lstStyle/>
           <a:p>
-            <a:pPr algn="l"/>
+            <a:pPr algn="l">
+              <a:lnSpc>
+                <a:spcPct val="115000"/>
+              </a:lnSpc>
+              <a:spcBef>
+                <a:spcPts val="0"/>
+              </a:spcBef>
+              <a:spcAft>
+                <a:spcPts val="200"/>
+              </a:spcAft>
+            </a:pPr>
             <a:r>
               <a:rPr sz="1400" b="1" i="0">
                 <a:solidFill>
@@ -6139,7 +6737,17 @@
           </a:bodyPr>
           <a:lstStyle/>
           <a:p>
-            <a:pPr algn="l"/>
+            <a:pPr algn="l">
+              <a:lnSpc>
+                <a:spcPct val="115000"/>
+              </a:lnSpc>
+              <a:spcBef>
+                <a:spcPts val="0"/>
+              </a:spcBef>
+              <a:spcAft>
+                <a:spcPts val="200"/>
+              </a:spcAft>
+            </a:pPr>
             <a:r>
               <a:rPr sz="1300" b="0" i="0">
                 <a:solidFill>
@@ -6219,7 +6827,17 @@
           </a:bodyPr>
           <a:lstStyle/>
           <a:p>
-            <a:pPr algn="l"/>
+            <a:pPr algn="l">
+              <a:lnSpc>
+                <a:spcPct val="115000"/>
+              </a:lnSpc>
+              <a:spcBef>
+                <a:spcPts val="0"/>
+              </a:spcBef>
+              <a:spcAft>
+                <a:spcPts val="200"/>
+              </a:spcAft>
+            </a:pPr>
             <a:r>
               <a:rPr sz="1400" b="1" i="0">
                 <a:solidFill>
@@ -6254,7 +6872,17 @@
           </a:bodyPr>
           <a:lstStyle/>
           <a:p>
-            <a:pPr algn="l"/>
+            <a:pPr algn="l">
+              <a:lnSpc>
+                <a:spcPct val="115000"/>
+              </a:lnSpc>
+              <a:spcBef>
+                <a:spcPts val="0"/>
+              </a:spcBef>
+              <a:spcAft>
+                <a:spcPts val="200"/>
+              </a:spcAft>
+            </a:pPr>
             <a:r>
               <a:rPr sz="1300" b="0" i="0">
                 <a:solidFill>
@@ -6334,7 +6962,17 @@
           </a:bodyPr>
           <a:lstStyle/>
           <a:p>
-            <a:pPr algn="l"/>
+            <a:pPr algn="l">
+              <a:lnSpc>
+                <a:spcPct val="115000"/>
+              </a:lnSpc>
+              <a:spcBef>
+                <a:spcPts val="0"/>
+              </a:spcBef>
+              <a:spcAft>
+                <a:spcPts val="200"/>
+              </a:spcAft>
+            </a:pPr>
             <a:r>
               <a:rPr sz="1400" b="1" i="0">
                 <a:solidFill>
@@ -6369,7 +7007,17 @@
           </a:bodyPr>
           <a:lstStyle/>
           <a:p>
-            <a:pPr algn="l"/>
+            <a:pPr algn="l">
+              <a:lnSpc>
+                <a:spcPct val="115000"/>
+              </a:lnSpc>
+              <a:spcBef>
+                <a:spcPts val="0"/>
+              </a:spcBef>
+              <a:spcAft>
+                <a:spcPts val="200"/>
+              </a:spcAft>
+            </a:pPr>
             <a:r>
               <a:rPr sz="1300" b="0" i="0">
                 <a:solidFill>
@@ -6447,7 +7095,17 @@
           </a:bodyPr>
           <a:lstStyle/>
           <a:p>
-            <a:pPr algn="l"/>
+            <a:pPr algn="l">
+              <a:lnSpc>
+                <a:spcPct val="115000"/>
+              </a:lnSpc>
+              <a:spcBef>
+                <a:spcPts val="0"/>
+              </a:spcBef>
+              <a:spcAft>
+                <a:spcPts val="200"/>
+              </a:spcAft>
+            </a:pPr>
             <a:r>
               <a:rPr sz="900" b="0" i="0">
                 <a:solidFill>
@@ -6482,7 +7140,17 @@
           </a:bodyPr>
           <a:lstStyle/>
           <a:p>
-            <a:pPr algn="r"/>
+            <a:pPr algn="r">
+              <a:lnSpc>
+                <a:spcPct val="115000"/>
+              </a:lnSpc>
+              <a:spcBef>
+                <a:spcPts val="0"/>
+              </a:spcBef>
+              <a:spcAft>
+                <a:spcPts val="200"/>
+              </a:spcAft>
+            </a:pPr>
             <a:r>
               <a:rPr sz="900" b="0" i="0">
                 <a:solidFill>
@@ -6621,7 +7289,17 @@
           </a:bodyPr>
           <a:lstStyle/>
           <a:p>
-            <a:pPr algn="l"/>
+            <a:pPr algn="l">
+              <a:lnSpc>
+                <a:spcPct val="115000"/>
+              </a:lnSpc>
+              <a:spcBef>
+                <a:spcPts val="0"/>
+              </a:spcBef>
+              <a:spcAft>
+                <a:spcPts val="200"/>
+              </a:spcAft>
+            </a:pPr>
             <a:r>
               <a:rPr sz="1100" b="1" i="0">
                 <a:solidFill>
@@ -6656,7 +7334,17 @@
           </a:bodyPr>
           <a:lstStyle/>
           <a:p>
-            <a:pPr algn="l"/>
+            <a:pPr algn="l">
+              <a:lnSpc>
+                <a:spcPct val="115000"/>
+              </a:lnSpc>
+              <a:spcBef>
+                <a:spcPts val="0"/>
+              </a:spcBef>
+              <a:spcAft>
+                <a:spcPts val="200"/>
+              </a:spcAft>
+            </a:pPr>
             <a:r>
               <a:rPr sz="2400" b="1" i="0">
                 <a:solidFill>
@@ -6736,7 +7424,17 @@
           </a:bodyPr>
           <a:lstStyle/>
           <a:p>
-            <a:pPr algn="l"/>
+            <a:pPr algn="l">
+              <a:lnSpc>
+                <a:spcPct val="115000"/>
+              </a:lnSpc>
+              <a:spcBef>
+                <a:spcPts val="0"/>
+              </a:spcBef>
+              <a:spcAft>
+                <a:spcPts val="200"/>
+              </a:spcAft>
+            </a:pPr>
             <a:r>
               <a:rPr sz="1300" b="1" i="0">
                 <a:solidFill>
@@ -6771,7 +7469,17 @@
           </a:bodyPr>
           <a:lstStyle/>
           <a:p>
-            <a:pPr algn="l"/>
+            <a:pPr algn="l">
+              <a:lnSpc>
+                <a:spcPct val="115000"/>
+              </a:lnSpc>
+              <a:spcBef>
+                <a:spcPts val="0"/>
+              </a:spcBef>
+              <a:spcAft>
+                <a:spcPts val="200"/>
+              </a:spcAft>
+            </a:pPr>
             <a:r>
               <a:rPr sz="1300" b="0" i="0">
                 <a:solidFill>
@@ -6851,7 +7559,17 @@
           </a:bodyPr>
           <a:lstStyle/>
           <a:p>
-            <a:pPr algn="l"/>
+            <a:pPr algn="l">
+              <a:lnSpc>
+                <a:spcPct val="115000"/>
+              </a:lnSpc>
+              <a:spcBef>
+                <a:spcPts val="0"/>
+              </a:spcBef>
+              <a:spcAft>
+                <a:spcPts val="200"/>
+              </a:spcAft>
+            </a:pPr>
             <a:r>
               <a:rPr sz="1300" b="1" i="0">
                 <a:solidFill>
@@ -6886,7 +7604,17 @@
           </a:bodyPr>
           <a:lstStyle/>
           <a:p>
-            <a:pPr algn="l"/>
+            <a:pPr algn="l">
+              <a:lnSpc>
+                <a:spcPct val="115000"/>
+              </a:lnSpc>
+              <a:spcBef>
+                <a:spcPts val="0"/>
+              </a:spcBef>
+              <a:spcAft>
+                <a:spcPts val="200"/>
+              </a:spcAft>
+            </a:pPr>
             <a:r>
               <a:rPr sz="1300" b="0" i="0">
                 <a:solidFill>
@@ -6966,7 +7694,17 @@
           </a:bodyPr>
           <a:lstStyle/>
           <a:p>
-            <a:pPr algn="l"/>
+            <a:pPr algn="l">
+              <a:lnSpc>
+                <a:spcPct val="115000"/>
+              </a:lnSpc>
+              <a:spcBef>
+                <a:spcPts val="0"/>
+              </a:spcBef>
+              <a:spcAft>
+                <a:spcPts val="200"/>
+              </a:spcAft>
+            </a:pPr>
             <a:r>
               <a:rPr sz="1300" b="1" i="0">
                 <a:solidFill>
@@ -7001,7 +7739,17 @@
           </a:bodyPr>
           <a:lstStyle/>
           <a:p>
-            <a:pPr algn="l"/>
+            <a:pPr algn="l">
+              <a:lnSpc>
+                <a:spcPct val="115000"/>
+              </a:lnSpc>
+              <a:spcBef>
+                <a:spcPts val="0"/>
+              </a:spcBef>
+              <a:spcAft>
+                <a:spcPts val="200"/>
+              </a:spcAft>
+            </a:pPr>
             <a:r>
               <a:rPr sz="1300" b="0" i="0">
                 <a:solidFill>
@@ -7081,7 +7829,17 @@
           </a:bodyPr>
           <a:lstStyle/>
           <a:p>
-            <a:pPr algn="l"/>
+            <a:pPr algn="l">
+              <a:lnSpc>
+                <a:spcPct val="115000"/>
+              </a:lnSpc>
+              <a:spcBef>
+                <a:spcPts val="0"/>
+              </a:spcBef>
+              <a:spcAft>
+                <a:spcPts val="200"/>
+              </a:spcAft>
+            </a:pPr>
             <a:r>
               <a:rPr sz="1300" b="1" i="0">
                 <a:solidFill>
@@ -7116,7 +7874,17 @@
           </a:bodyPr>
           <a:lstStyle/>
           <a:p>
-            <a:pPr algn="l"/>
+            <a:pPr algn="l">
+              <a:lnSpc>
+                <a:spcPct val="115000"/>
+              </a:lnSpc>
+              <a:spcBef>
+                <a:spcPts val="0"/>
+              </a:spcBef>
+              <a:spcAft>
+                <a:spcPts val="200"/>
+              </a:spcAft>
+            </a:pPr>
             <a:r>
               <a:rPr sz="1300" b="0" i="0">
                 <a:solidFill>
@@ -7194,7 +7962,17 @@
           </a:bodyPr>
           <a:lstStyle/>
           <a:p>
-            <a:pPr algn="l"/>
+            <a:pPr algn="l">
+              <a:lnSpc>
+                <a:spcPct val="115000"/>
+              </a:lnSpc>
+              <a:spcBef>
+                <a:spcPts val="0"/>
+              </a:spcBef>
+              <a:spcAft>
+                <a:spcPts val="200"/>
+              </a:spcAft>
+            </a:pPr>
             <a:r>
               <a:rPr sz="900" b="0" i="0">
                 <a:solidFill>
@@ -7229,7 +8007,17 @@
           </a:bodyPr>
           <a:lstStyle/>
           <a:p>
-            <a:pPr algn="r"/>
+            <a:pPr algn="r">
+              <a:lnSpc>
+                <a:spcPct val="115000"/>
+              </a:lnSpc>
+              <a:spcBef>
+                <a:spcPts val="0"/>
+              </a:spcBef>
+              <a:spcAft>
+                <a:spcPts val="200"/>
+              </a:spcAft>
+            </a:pPr>
             <a:r>
               <a:rPr sz="900" b="0" i="0">
                 <a:solidFill>
@@ -7368,7 +8156,17 @@
           </a:bodyPr>
           <a:lstStyle/>
           <a:p>
-            <a:pPr algn="l"/>
+            <a:pPr algn="l">
+              <a:lnSpc>
+                <a:spcPct val="115000"/>
+              </a:lnSpc>
+              <a:spcBef>
+                <a:spcPts val="0"/>
+              </a:spcBef>
+              <a:spcAft>
+                <a:spcPts val="200"/>
+              </a:spcAft>
+            </a:pPr>
             <a:r>
               <a:rPr sz="1100" b="1" i="0">
                 <a:solidFill>
@@ -7403,7 +8201,17 @@
           </a:bodyPr>
           <a:lstStyle/>
           <a:p>
-            <a:pPr algn="l"/>
+            <a:pPr algn="l">
+              <a:lnSpc>
+                <a:spcPct val="115000"/>
+              </a:lnSpc>
+              <a:spcBef>
+                <a:spcPts val="0"/>
+              </a:spcBef>
+              <a:spcAft>
+                <a:spcPts val="200"/>
+              </a:spcAft>
+            </a:pPr>
             <a:r>
               <a:rPr sz="2400" b="1" i="0">
                 <a:solidFill>
@@ -7462,19 +8270,113 @@
           </a:bodyPr>
           <a:lstStyle/>
           <a:p>
-            <a:pPr algn="l"/>
-            <a:r>
-              <a:rPr sz="1600" b="0" i="0">
+            <a:pPr algn="l">
+              <a:lnSpc>
+                <a:spcPct val="128000"/>
+              </a:lnSpc>
+              <a:spcBef>
+                <a:spcPts val="0"/>
+              </a:spcBef>
+              <a:spcAft>
+                <a:spcPts val="1400"/>
+              </a:spcAft>
+            </a:pPr>
+            <a:r>
+              <a:rPr sz="2600" b="0" i="0">
                 <a:solidFill>
                   <a:srgbClr val="1E2F38"/>
                 </a:solidFill>
                 <a:latin typeface="Calibri"/>
               </a:rPr>
-              <a:t>• FairBanks Medical Centre + Community Reach
-• CHW/VHT networks in Kampala catchments
-• Maternal, child, chronic, and outreach programmes
-• FCHIP intelligence layer in development
-• Employer ready to host field placement</a:t>
+              <a:t>• FairBanks Medical Centre + Community Reach</a:t>
+            </a:r>
+          </a:p>
+          <a:p>
+            <a:pPr algn="l">
+              <a:lnSpc>
+                <a:spcPct val="128000"/>
+              </a:lnSpc>
+              <a:spcBef>
+                <a:spcPts val="0"/>
+              </a:spcBef>
+              <a:spcAft>
+                <a:spcPts val="1400"/>
+              </a:spcAft>
+            </a:pPr>
+            <a:r>
+              <a:rPr sz="2600" b="0" i="0">
+                <a:solidFill>
+                  <a:srgbClr val="1E2F38"/>
+                </a:solidFill>
+                <a:latin typeface="Calibri"/>
+              </a:rPr>
+              <a:t>• CHW/VHT networks in Kampala catchments</a:t>
+            </a:r>
+          </a:p>
+          <a:p>
+            <a:pPr algn="l">
+              <a:lnSpc>
+                <a:spcPct val="128000"/>
+              </a:lnSpc>
+              <a:spcBef>
+                <a:spcPts val="0"/>
+              </a:spcBef>
+              <a:spcAft>
+                <a:spcPts val="1400"/>
+              </a:spcAft>
+            </a:pPr>
+            <a:r>
+              <a:rPr sz="2600" b="0" i="0">
+                <a:solidFill>
+                  <a:srgbClr val="1E2F38"/>
+                </a:solidFill>
+                <a:latin typeface="Calibri"/>
+              </a:rPr>
+              <a:t>• Maternal, child, chronic, and outreach programmes</a:t>
+            </a:r>
+          </a:p>
+          <a:p>
+            <a:pPr algn="l">
+              <a:lnSpc>
+                <a:spcPct val="128000"/>
+              </a:lnSpc>
+              <a:spcBef>
+                <a:spcPts val="0"/>
+              </a:spcBef>
+              <a:spcAft>
+                <a:spcPts val="1400"/>
+              </a:spcAft>
+            </a:pPr>
+            <a:r>
+              <a:rPr sz="2600" b="0" i="0">
+                <a:solidFill>
+                  <a:srgbClr val="1E2F38"/>
+                </a:solidFill>
+                <a:latin typeface="Calibri"/>
+              </a:rPr>
+              <a:t>• FCHIP intelligence layer in development</a:t>
+            </a:r>
+          </a:p>
+          <a:p>
+            <a:pPr algn="l">
+              <a:lnSpc>
+                <a:spcPct val="128000"/>
+              </a:lnSpc>
+              <a:spcBef>
+                <a:spcPts val="0"/>
+              </a:spcBef>
+              <a:spcAft>
+                <a:spcPts val="200"/>
+              </a:spcAft>
+            </a:pPr>
+            <a:r>
+              <a:rPr sz="2600" b="0" i="0">
+                <a:solidFill>
+                  <a:srgbClr val="1E2F38"/>
+                </a:solidFill>
+                <a:latin typeface="Calibri"/>
+              </a:rPr>
+              <a:t>• Employer ready to host field placement</a:t>
             </a:r>
           </a:p>
         </p:txBody>
@@ -7544,7 +8446,17 @@
           </a:bodyPr>
           <a:lstStyle/>
           <a:p>
-            <a:pPr algn="l"/>
+            <a:pPr algn="l">
+              <a:lnSpc>
+                <a:spcPct val="115000"/>
+              </a:lnSpc>
+              <a:spcBef>
+                <a:spcPts val="0"/>
+              </a:spcBef>
+              <a:spcAft>
+                <a:spcPts val="200"/>
+              </a:spcAft>
+            </a:pPr>
             <a:r>
               <a:rPr sz="900" b="0" i="0">
                 <a:solidFill>
@@ -7579,7 +8491,17 @@
           </a:bodyPr>
           <a:lstStyle/>
           <a:p>
-            <a:pPr algn="r"/>
+            <a:pPr algn="r">
+              <a:lnSpc>
+                <a:spcPct val="115000"/>
+              </a:lnSpc>
+              <a:spcBef>
+                <a:spcPts val="0"/>
+              </a:spcBef>
+              <a:spcAft>
+                <a:spcPts val="200"/>
+              </a:spcAft>
+            </a:pPr>
             <a:r>
               <a:rPr sz="900" b="0" i="0">
                 <a:solidFill>

</xml_diff>

<commit_message>
Add entrance animations to PowerPoint slides across multiple applications. Implement a new function to create light fade-in effects for images and key text, enhancing visual engagement. Update build scripts to apply these animations consistently in generated presentations.
</commit_message>
<xml_diff>
--- a/applications/africa-cdc/documents/africa-cdc_ppt.pptx
+++ b/applications/africa-cdc/documents/africa-cdc_ppt.pptx
@@ -3394,6 +3394,96 @@
   <p:clrMapOvr>
     <a:masterClrMapping/>
   </p:clrMapOvr>
+  <p:timing>
+    <p:tnLst>
+      <p:par>
+        <p:cTn id="1" dur="indefinite" restart="never" nodeType="tmRoot">
+          <p:childTnLst>
+            <p:seq concurrent="true" nextAc="seek">
+              <p:cTn id="2" dur="indefinite" nodeType="mainSeq">
+                <p:childTnLst>
+                  <p:par>
+                    <p:cTn id="9" fill="hold">
+                      <p:stCondLst>
+                        <p:cond delay="0"/>
+                      </p:stCondLst>
+                      <p:childTnLst>
+                        <p:par>
+                          <p:cTn id="3" presetID="10" presetClass="entr" presetSubtype="0" fill="hold" nodeType="withEffect">
+                            <p:stCondLst>
+                              <p:cond delay="0"/>
+                            </p:stCondLst>
+                            <p:childTnLst>
+                              <p:animEffect transition="in" filter="fade">
+                                <p:cBhvr>
+                                  <p:cTn id="4" dur="450"/>
+                                  <p:tgtEl>
+                                    <p:spTgt spid="2"/>
+                                  </p:tgtEl>
+                                </p:cBhvr>
+                              </p:animEffect>
+                            </p:childTnLst>
+                          </p:cTn>
+                        </p:par>
+                        <p:par>
+                          <p:cTn id="5" presetID="10" presetClass="entr" presetSubtype="0" fill="hold" nodeType="withEffect">
+                            <p:stCondLst>
+                              <p:cond delay="200"/>
+                            </p:stCondLst>
+                            <p:childTnLst>
+                              <p:animEffect transition="in" filter="fade">
+                                <p:cBhvr>
+                                  <p:cTn id="6" dur="450"/>
+                                  <p:tgtEl>
+                                    <p:spTgt spid="3"/>
+                                  </p:tgtEl>
+                                </p:cBhvr>
+                              </p:animEffect>
+                            </p:childTnLst>
+                          </p:cTn>
+                        </p:par>
+                        <p:par>
+                          <p:cTn id="7" presetID="10" presetClass="entr" presetSubtype="0" fill="hold" nodeType="withEffect">
+                            <p:stCondLst>
+                              <p:cond delay="200"/>
+                            </p:stCondLst>
+                            <p:childTnLst>
+                              <p:animEffect transition="in" filter="fade">
+                                <p:cBhvr>
+                                  <p:cTn id="8" dur="450"/>
+                                  <p:tgtEl>
+                                    <p:spTgt spid="4"/>
+                                  </p:tgtEl>
+                                </p:cBhvr>
+                              </p:animEffect>
+                            </p:childTnLst>
+                          </p:cTn>
+                        </p:par>
+                      </p:childTnLst>
+                    </p:cTn>
+                  </p:par>
+                </p:childTnLst>
+              </p:cTn>
+              <p:prevCondLst>
+                <p:cond evt="onPrev" delay="0">
+                  <p:tgtEl>
+                    <p:sldTgt/>
+                  </p:tgtEl>
+                </p:cond>
+              </p:prevCondLst>
+              <p:nextCondLst>
+                <p:cond evt="onNext" delay="0">
+                  <p:tgtEl>
+                    <p:sldTgt/>
+                  </p:tgtEl>
+                </p:cond>
+              </p:nextCondLst>
+            </p:seq>
+          </p:childTnLst>
+        </p:cTn>
+      </p:par>
+    </p:tnLst>
+  </p:timing>
 </p:sld>
 </file>
 
@@ -3614,6 +3704,96 @@
   <p:clrMapOvr>
     <a:masterClrMapping/>
   </p:clrMapOvr>
+  <p:timing>
+    <p:tnLst>
+      <p:par>
+        <p:cTn id="1" dur="indefinite" restart="never" nodeType="tmRoot">
+          <p:childTnLst>
+            <p:seq concurrent="true" nextAc="seek">
+              <p:cTn id="2" dur="indefinite" nodeType="mainSeq">
+                <p:childTnLst>
+                  <p:par>
+                    <p:cTn id="9" fill="hold">
+                      <p:stCondLst>
+                        <p:cond delay="0"/>
+                      </p:stCondLst>
+                      <p:childTnLst>
+                        <p:par>
+                          <p:cTn id="3" presetID="10" presetClass="entr" presetSubtype="0" fill="hold" nodeType="withEffect">
+                            <p:stCondLst>
+                              <p:cond delay="0"/>
+                            </p:stCondLst>
+                            <p:childTnLst>
+                              <p:animEffect transition="in" filter="fade">
+                                <p:cBhvr>
+                                  <p:cTn id="4" dur="450"/>
+                                  <p:tgtEl>
+                                    <p:spTgt spid="2"/>
+                                  </p:tgtEl>
+                                </p:cBhvr>
+                              </p:animEffect>
+                            </p:childTnLst>
+                          </p:cTn>
+                        </p:par>
+                        <p:par>
+                          <p:cTn id="5" presetID="10" presetClass="entr" presetSubtype="0" fill="hold" nodeType="withEffect">
+                            <p:stCondLst>
+                              <p:cond delay="200"/>
+                            </p:stCondLst>
+                            <p:childTnLst>
+                              <p:animEffect transition="in" filter="fade">
+                                <p:cBhvr>
+                                  <p:cTn id="6" dur="450"/>
+                                  <p:tgtEl>
+                                    <p:spTgt spid="3"/>
+                                  </p:tgtEl>
+                                </p:cBhvr>
+                              </p:animEffect>
+                            </p:childTnLst>
+                          </p:cTn>
+                        </p:par>
+                        <p:par>
+                          <p:cTn id="7" presetID="10" presetClass="entr" presetSubtype="0" fill="hold" nodeType="withEffect">
+                            <p:stCondLst>
+                              <p:cond delay="200"/>
+                            </p:stCondLst>
+                            <p:childTnLst>
+                              <p:animEffect transition="in" filter="fade">
+                                <p:cBhvr>
+                                  <p:cTn id="8" dur="450"/>
+                                  <p:tgtEl>
+                                    <p:spTgt spid="4"/>
+                                  </p:tgtEl>
+                                </p:cBhvr>
+                              </p:animEffect>
+                            </p:childTnLst>
+                          </p:cTn>
+                        </p:par>
+                      </p:childTnLst>
+                    </p:cTn>
+                  </p:par>
+                </p:childTnLst>
+              </p:cTn>
+              <p:prevCondLst>
+                <p:cond evt="onPrev" delay="0">
+                  <p:tgtEl>
+                    <p:sldTgt/>
+                  </p:tgtEl>
+                </p:cond>
+              </p:prevCondLst>
+              <p:nextCondLst>
+                <p:cond evt="onNext" delay="0">
+                  <p:tgtEl>
+                    <p:sldTgt/>
+                  </p:tgtEl>
+                </p:cond>
+              </p:nextCondLst>
+            </p:seq>
+          </p:childTnLst>
+        </p:cTn>
+      </p:par>
+    </p:tnLst>
+  </p:timing>
 </p:sld>
 </file>
 
@@ -4098,6 +4278,96 @@
   <p:clrMapOvr>
     <a:masterClrMapping/>
   </p:clrMapOvr>
+  <p:timing>
+    <p:tnLst>
+      <p:par>
+        <p:cTn id="1" dur="indefinite" restart="never" nodeType="tmRoot">
+          <p:childTnLst>
+            <p:seq concurrent="true" nextAc="seek">
+              <p:cTn id="2" dur="indefinite" nodeType="mainSeq">
+                <p:childTnLst>
+                  <p:par>
+                    <p:cTn id="9" fill="hold">
+                      <p:stCondLst>
+                        <p:cond delay="0"/>
+                      </p:stCondLst>
+                      <p:childTnLst>
+                        <p:par>
+                          <p:cTn id="3" presetID="10" presetClass="entr" presetSubtype="0" fill="hold" nodeType="withEffect">
+                            <p:stCondLst>
+                              <p:cond delay="0"/>
+                            </p:stCondLst>
+                            <p:childTnLst>
+                              <p:animEffect transition="in" filter="fade">
+                                <p:cBhvr>
+                                  <p:cTn id="4" dur="450"/>
+                                  <p:tgtEl>
+                                    <p:spTgt spid="2"/>
+                                  </p:tgtEl>
+                                </p:cBhvr>
+                              </p:animEffect>
+                            </p:childTnLst>
+                          </p:cTn>
+                        </p:par>
+                        <p:par>
+                          <p:cTn id="5" presetID="10" presetClass="entr" presetSubtype="0" fill="hold" nodeType="withEffect">
+                            <p:stCondLst>
+                              <p:cond delay="200"/>
+                            </p:stCondLst>
+                            <p:childTnLst>
+                              <p:animEffect transition="in" filter="fade">
+                                <p:cBhvr>
+                                  <p:cTn id="6" dur="450"/>
+                                  <p:tgtEl>
+                                    <p:spTgt spid="3"/>
+                                  </p:tgtEl>
+                                </p:cBhvr>
+                              </p:animEffect>
+                            </p:childTnLst>
+                          </p:cTn>
+                        </p:par>
+                        <p:par>
+                          <p:cTn id="7" presetID="10" presetClass="entr" presetSubtype="0" fill="hold" nodeType="withEffect">
+                            <p:stCondLst>
+                              <p:cond delay="200"/>
+                            </p:stCondLst>
+                            <p:childTnLst>
+                              <p:animEffect transition="in" filter="fade">
+                                <p:cBhvr>
+                                  <p:cTn id="8" dur="450"/>
+                                  <p:tgtEl>
+                                    <p:spTgt spid="4"/>
+                                  </p:tgtEl>
+                                </p:cBhvr>
+                              </p:animEffect>
+                            </p:childTnLst>
+                          </p:cTn>
+                        </p:par>
+                      </p:childTnLst>
+                    </p:cTn>
+                  </p:par>
+                </p:childTnLst>
+              </p:cTn>
+              <p:prevCondLst>
+                <p:cond evt="onPrev" delay="0">
+                  <p:tgtEl>
+                    <p:sldTgt/>
+                  </p:tgtEl>
+                </p:cond>
+              </p:prevCondLst>
+              <p:nextCondLst>
+                <p:cond evt="onNext" delay="0">
+                  <p:tgtEl>
+                    <p:sldTgt/>
+                  </p:tgtEl>
+                </p:cond>
+              </p:nextCondLst>
+            </p:seq>
+          </p:childTnLst>
+        </p:cTn>
+      </p:par>
+    </p:tnLst>
+  </p:timing>
 </p:sld>
 </file>
 
@@ -4516,6 +4786,96 @@
   <p:clrMapOvr>
     <a:masterClrMapping/>
   </p:clrMapOvr>
+  <p:timing>
+    <p:tnLst>
+      <p:par>
+        <p:cTn id="1" dur="indefinite" restart="never" nodeType="tmRoot">
+          <p:childTnLst>
+            <p:seq concurrent="true" nextAc="seek">
+              <p:cTn id="2" dur="indefinite" nodeType="mainSeq">
+                <p:childTnLst>
+                  <p:par>
+                    <p:cTn id="9" fill="hold">
+                      <p:stCondLst>
+                        <p:cond delay="0"/>
+                      </p:stCondLst>
+                      <p:childTnLst>
+                        <p:par>
+                          <p:cTn id="3" presetID="10" presetClass="entr" presetSubtype="0" fill="hold" nodeType="withEffect">
+                            <p:stCondLst>
+                              <p:cond delay="0"/>
+                            </p:stCondLst>
+                            <p:childTnLst>
+                              <p:animEffect transition="in" filter="fade">
+                                <p:cBhvr>
+                                  <p:cTn id="4" dur="450"/>
+                                  <p:tgtEl>
+                                    <p:spTgt spid="2"/>
+                                  </p:tgtEl>
+                                </p:cBhvr>
+                              </p:animEffect>
+                            </p:childTnLst>
+                          </p:cTn>
+                        </p:par>
+                        <p:par>
+                          <p:cTn id="5" presetID="10" presetClass="entr" presetSubtype="0" fill="hold" nodeType="withEffect">
+                            <p:stCondLst>
+                              <p:cond delay="200"/>
+                            </p:stCondLst>
+                            <p:childTnLst>
+                              <p:animEffect transition="in" filter="fade">
+                                <p:cBhvr>
+                                  <p:cTn id="6" dur="450"/>
+                                  <p:tgtEl>
+                                    <p:spTgt spid="3"/>
+                                  </p:tgtEl>
+                                </p:cBhvr>
+                              </p:animEffect>
+                            </p:childTnLst>
+                          </p:cTn>
+                        </p:par>
+                        <p:par>
+                          <p:cTn id="7" presetID="10" presetClass="entr" presetSubtype="0" fill="hold" nodeType="withEffect">
+                            <p:stCondLst>
+                              <p:cond delay="200"/>
+                            </p:stCondLst>
+                            <p:childTnLst>
+                              <p:animEffect transition="in" filter="fade">
+                                <p:cBhvr>
+                                  <p:cTn id="8" dur="450"/>
+                                  <p:tgtEl>
+                                    <p:spTgt spid="4"/>
+                                  </p:tgtEl>
+                                </p:cBhvr>
+                              </p:animEffect>
+                            </p:childTnLst>
+                          </p:cTn>
+                        </p:par>
+                      </p:childTnLst>
+                    </p:cTn>
+                  </p:par>
+                </p:childTnLst>
+              </p:cTn>
+              <p:prevCondLst>
+                <p:cond evt="onPrev" delay="0">
+                  <p:tgtEl>
+                    <p:sldTgt/>
+                  </p:tgtEl>
+                </p:cond>
+              </p:prevCondLst>
+              <p:nextCondLst>
+                <p:cond evt="onNext" delay="0">
+                  <p:tgtEl>
+                    <p:sldTgt/>
+                  </p:tgtEl>
+                </p:cond>
+              </p:nextCondLst>
+            </p:seq>
+          </p:childTnLst>
+        </p:cTn>
+      </p:par>
+    </p:tnLst>
+  </p:timing>
 </p:sld>
 </file>
 
@@ -4978,6 +5338,96 @@
   <p:clrMapOvr>
     <a:masterClrMapping/>
   </p:clrMapOvr>
+  <p:timing>
+    <p:tnLst>
+      <p:par>
+        <p:cTn id="1" dur="indefinite" restart="never" nodeType="tmRoot">
+          <p:childTnLst>
+            <p:seq concurrent="true" nextAc="seek">
+              <p:cTn id="2" dur="indefinite" nodeType="mainSeq">
+                <p:childTnLst>
+                  <p:par>
+                    <p:cTn id="9" fill="hold">
+                      <p:stCondLst>
+                        <p:cond delay="0"/>
+                      </p:stCondLst>
+                      <p:childTnLst>
+                        <p:par>
+                          <p:cTn id="3" presetID="10" presetClass="entr" presetSubtype="0" fill="hold" nodeType="withEffect">
+                            <p:stCondLst>
+                              <p:cond delay="0"/>
+                            </p:stCondLst>
+                            <p:childTnLst>
+                              <p:animEffect transition="in" filter="fade">
+                                <p:cBhvr>
+                                  <p:cTn id="4" dur="450"/>
+                                  <p:tgtEl>
+                                    <p:spTgt spid="2"/>
+                                  </p:tgtEl>
+                                </p:cBhvr>
+                              </p:animEffect>
+                            </p:childTnLst>
+                          </p:cTn>
+                        </p:par>
+                        <p:par>
+                          <p:cTn id="5" presetID="10" presetClass="entr" presetSubtype="0" fill="hold" nodeType="withEffect">
+                            <p:stCondLst>
+                              <p:cond delay="200"/>
+                            </p:stCondLst>
+                            <p:childTnLst>
+                              <p:animEffect transition="in" filter="fade">
+                                <p:cBhvr>
+                                  <p:cTn id="6" dur="450"/>
+                                  <p:tgtEl>
+                                    <p:spTgt spid="3"/>
+                                  </p:tgtEl>
+                                </p:cBhvr>
+                              </p:animEffect>
+                            </p:childTnLst>
+                          </p:cTn>
+                        </p:par>
+                        <p:par>
+                          <p:cTn id="7" presetID="10" presetClass="entr" presetSubtype="0" fill="hold" nodeType="withEffect">
+                            <p:stCondLst>
+                              <p:cond delay="200"/>
+                            </p:stCondLst>
+                            <p:childTnLst>
+                              <p:animEffect transition="in" filter="fade">
+                                <p:cBhvr>
+                                  <p:cTn id="8" dur="450"/>
+                                  <p:tgtEl>
+                                    <p:spTgt spid="4"/>
+                                  </p:tgtEl>
+                                </p:cBhvr>
+                              </p:animEffect>
+                            </p:childTnLst>
+                          </p:cTn>
+                        </p:par>
+                      </p:childTnLst>
+                    </p:cTn>
+                  </p:par>
+                </p:childTnLst>
+              </p:cTn>
+              <p:prevCondLst>
+                <p:cond evt="onPrev" delay="0">
+                  <p:tgtEl>
+                    <p:sldTgt/>
+                  </p:tgtEl>
+                </p:cond>
+              </p:prevCondLst>
+              <p:nextCondLst>
+                <p:cond evt="onNext" delay="0">
+                  <p:tgtEl>
+                    <p:sldTgt/>
+                  </p:tgtEl>
+                </p:cond>
+              </p:nextCondLst>
+            </p:seq>
+          </p:childTnLst>
+        </p:cTn>
+      </p:par>
+    </p:tnLst>
+  </p:timing>
 </p:sld>
 </file>
 
@@ -5575,6 +6025,96 @@
   <p:clrMapOvr>
     <a:masterClrMapping/>
   </p:clrMapOvr>
+  <p:timing>
+    <p:tnLst>
+      <p:par>
+        <p:cTn id="1" dur="indefinite" restart="never" nodeType="tmRoot">
+          <p:childTnLst>
+            <p:seq concurrent="true" nextAc="seek">
+              <p:cTn id="2" dur="indefinite" nodeType="mainSeq">
+                <p:childTnLst>
+                  <p:par>
+                    <p:cTn id="9" fill="hold">
+                      <p:stCondLst>
+                        <p:cond delay="0"/>
+                      </p:stCondLst>
+                      <p:childTnLst>
+                        <p:par>
+                          <p:cTn id="3" presetID="10" presetClass="entr" presetSubtype="0" fill="hold" nodeType="withEffect">
+                            <p:stCondLst>
+                              <p:cond delay="0"/>
+                            </p:stCondLst>
+                            <p:childTnLst>
+                              <p:animEffect transition="in" filter="fade">
+                                <p:cBhvr>
+                                  <p:cTn id="4" dur="450"/>
+                                  <p:tgtEl>
+                                    <p:spTgt spid="2"/>
+                                  </p:tgtEl>
+                                </p:cBhvr>
+                              </p:animEffect>
+                            </p:childTnLst>
+                          </p:cTn>
+                        </p:par>
+                        <p:par>
+                          <p:cTn id="5" presetID="10" presetClass="entr" presetSubtype="0" fill="hold" nodeType="withEffect">
+                            <p:stCondLst>
+                              <p:cond delay="200"/>
+                            </p:stCondLst>
+                            <p:childTnLst>
+                              <p:animEffect transition="in" filter="fade">
+                                <p:cBhvr>
+                                  <p:cTn id="6" dur="450"/>
+                                  <p:tgtEl>
+                                    <p:spTgt spid="3"/>
+                                  </p:tgtEl>
+                                </p:cBhvr>
+                              </p:animEffect>
+                            </p:childTnLst>
+                          </p:cTn>
+                        </p:par>
+                        <p:par>
+                          <p:cTn id="7" presetID="10" presetClass="entr" presetSubtype="0" fill="hold" nodeType="withEffect">
+                            <p:stCondLst>
+                              <p:cond delay="200"/>
+                            </p:stCondLst>
+                            <p:childTnLst>
+                              <p:animEffect transition="in" filter="fade">
+                                <p:cBhvr>
+                                  <p:cTn id="8" dur="450"/>
+                                  <p:tgtEl>
+                                    <p:spTgt spid="4"/>
+                                  </p:tgtEl>
+                                </p:cBhvr>
+                              </p:animEffect>
+                            </p:childTnLst>
+                          </p:cTn>
+                        </p:par>
+                      </p:childTnLst>
+                    </p:cTn>
+                  </p:par>
+                </p:childTnLst>
+              </p:cTn>
+              <p:prevCondLst>
+                <p:cond evt="onPrev" delay="0">
+                  <p:tgtEl>
+                    <p:sldTgt/>
+                  </p:tgtEl>
+                </p:cond>
+              </p:prevCondLst>
+              <p:nextCondLst>
+                <p:cond evt="onNext" delay="0">
+                  <p:tgtEl>
+                    <p:sldTgt/>
+                  </p:tgtEl>
+                </p:cond>
+              </p:nextCondLst>
+            </p:seq>
+          </p:childTnLst>
+        </p:cTn>
+      </p:par>
+    </p:tnLst>
+  </p:timing>
 </p:sld>
 </file>
 
@@ -6301,6 +6841,96 @@
   <p:clrMapOvr>
     <a:masterClrMapping/>
   </p:clrMapOvr>
+  <p:timing>
+    <p:tnLst>
+      <p:par>
+        <p:cTn id="1" dur="indefinite" restart="never" nodeType="tmRoot">
+          <p:childTnLst>
+            <p:seq concurrent="true" nextAc="seek">
+              <p:cTn id="2" dur="indefinite" nodeType="mainSeq">
+                <p:childTnLst>
+                  <p:par>
+                    <p:cTn id="9" fill="hold">
+                      <p:stCondLst>
+                        <p:cond delay="0"/>
+                      </p:stCondLst>
+                      <p:childTnLst>
+                        <p:par>
+                          <p:cTn id="3" presetID="10" presetClass="entr" presetSubtype="0" fill="hold" nodeType="withEffect">
+                            <p:stCondLst>
+                              <p:cond delay="0"/>
+                            </p:stCondLst>
+                            <p:childTnLst>
+                              <p:animEffect transition="in" filter="fade">
+                                <p:cBhvr>
+                                  <p:cTn id="4" dur="450"/>
+                                  <p:tgtEl>
+                                    <p:spTgt spid="2"/>
+                                  </p:tgtEl>
+                                </p:cBhvr>
+                              </p:animEffect>
+                            </p:childTnLst>
+                          </p:cTn>
+                        </p:par>
+                        <p:par>
+                          <p:cTn id="5" presetID="10" presetClass="entr" presetSubtype="0" fill="hold" nodeType="withEffect">
+                            <p:stCondLst>
+                              <p:cond delay="200"/>
+                            </p:stCondLst>
+                            <p:childTnLst>
+                              <p:animEffect transition="in" filter="fade">
+                                <p:cBhvr>
+                                  <p:cTn id="6" dur="450"/>
+                                  <p:tgtEl>
+                                    <p:spTgt spid="3"/>
+                                  </p:tgtEl>
+                                </p:cBhvr>
+                              </p:animEffect>
+                            </p:childTnLst>
+                          </p:cTn>
+                        </p:par>
+                        <p:par>
+                          <p:cTn id="7" presetID="10" presetClass="entr" presetSubtype="0" fill="hold" nodeType="withEffect">
+                            <p:stCondLst>
+                              <p:cond delay="200"/>
+                            </p:stCondLst>
+                            <p:childTnLst>
+                              <p:animEffect transition="in" filter="fade">
+                                <p:cBhvr>
+                                  <p:cTn id="8" dur="450"/>
+                                  <p:tgtEl>
+                                    <p:spTgt spid="4"/>
+                                  </p:tgtEl>
+                                </p:cBhvr>
+                              </p:animEffect>
+                            </p:childTnLst>
+                          </p:cTn>
+                        </p:par>
+                      </p:childTnLst>
+                    </p:cTn>
+                  </p:par>
+                </p:childTnLst>
+              </p:cTn>
+              <p:prevCondLst>
+                <p:cond evt="onPrev" delay="0">
+                  <p:tgtEl>
+                    <p:sldTgt/>
+                  </p:tgtEl>
+                </p:cond>
+              </p:prevCondLst>
+              <p:nextCondLst>
+                <p:cond evt="onNext" delay="0">
+                  <p:tgtEl>
+                    <p:sldTgt/>
+                  </p:tgtEl>
+                </p:cond>
+              </p:nextCondLst>
+            </p:seq>
+          </p:childTnLst>
+        </p:cTn>
+      </p:par>
+    </p:tnLst>
+  </p:timing>
 </p:sld>
 </file>
 
@@ -7168,6 +7798,96 @@
   <p:clrMapOvr>
     <a:masterClrMapping/>
   </p:clrMapOvr>
+  <p:timing>
+    <p:tnLst>
+      <p:par>
+        <p:cTn id="1" dur="indefinite" restart="never" nodeType="tmRoot">
+          <p:childTnLst>
+            <p:seq concurrent="true" nextAc="seek">
+              <p:cTn id="2" dur="indefinite" nodeType="mainSeq">
+                <p:childTnLst>
+                  <p:par>
+                    <p:cTn id="9" fill="hold">
+                      <p:stCondLst>
+                        <p:cond delay="0"/>
+                      </p:stCondLst>
+                      <p:childTnLst>
+                        <p:par>
+                          <p:cTn id="3" presetID="10" presetClass="entr" presetSubtype="0" fill="hold" nodeType="withEffect">
+                            <p:stCondLst>
+                              <p:cond delay="0"/>
+                            </p:stCondLst>
+                            <p:childTnLst>
+                              <p:animEffect transition="in" filter="fade">
+                                <p:cBhvr>
+                                  <p:cTn id="4" dur="450"/>
+                                  <p:tgtEl>
+                                    <p:spTgt spid="2"/>
+                                  </p:tgtEl>
+                                </p:cBhvr>
+                              </p:animEffect>
+                            </p:childTnLst>
+                          </p:cTn>
+                        </p:par>
+                        <p:par>
+                          <p:cTn id="5" presetID="10" presetClass="entr" presetSubtype="0" fill="hold" nodeType="withEffect">
+                            <p:stCondLst>
+                              <p:cond delay="200"/>
+                            </p:stCondLst>
+                            <p:childTnLst>
+                              <p:animEffect transition="in" filter="fade">
+                                <p:cBhvr>
+                                  <p:cTn id="6" dur="450"/>
+                                  <p:tgtEl>
+                                    <p:spTgt spid="3"/>
+                                  </p:tgtEl>
+                                </p:cBhvr>
+                              </p:animEffect>
+                            </p:childTnLst>
+                          </p:cTn>
+                        </p:par>
+                        <p:par>
+                          <p:cTn id="7" presetID="10" presetClass="entr" presetSubtype="0" fill="hold" nodeType="withEffect">
+                            <p:stCondLst>
+                              <p:cond delay="200"/>
+                            </p:stCondLst>
+                            <p:childTnLst>
+                              <p:animEffect transition="in" filter="fade">
+                                <p:cBhvr>
+                                  <p:cTn id="8" dur="450"/>
+                                  <p:tgtEl>
+                                    <p:spTgt spid="4"/>
+                                  </p:tgtEl>
+                                </p:cBhvr>
+                              </p:animEffect>
+                            </p:childTnLst>
+                          </p:cTn>
+                        </p:par>
+                      </p:childTnLst>
+                    </p:cTn>
+                  </p:par>
+                </p:childTnLst>
+              </p:cTn>
+              <p:prevCondLst>
+                <p:cond evt="onPrev" delay="0">
+                  <p:tgtEl>
+                    <p:sldTgt/>
+                  </p:tgtEl>
+                </p:cond>
+              </p:prevCondLst>
+              <p:nextCondLst>
+                <p:cond evt="onNext" delay="0">
+                  <p:tgtEl>
+                    <p:sldTgt/>
+                  </p:tgtEl>
+                </p:cond>
+              </p:nextCondLst>
+            </p:seq>
+          </p:childTnLst>
+        </p:cTn>
+      </p:par>
+    </p:tnLst>
+  </p:timing>
 </p:sld>
 </file>
 
@@ -8035,6 +8755,96 @@
   <p:clrMapOvr>
     <a:masterClrMapping/>
   </p:clrMapOvr>
+  <p:timing>
+    <p:tnLst>
+      <p:par>
+        <p:cTn id="1" dur="indefinite" restart="never" nodeType="tmRoot">
+          <p:childTnLst>
+            <p:seq concurrent="true" nextAc="seek">
+              <p:cTn id="2" dur="indefinite" nodeType="mainSeq">
+                <p:childTnLst>
+                  <p:par>
+                    <p:cTn id="9" fill="hold">
+                      <p:stCondLst>
+                        <p:cond delay="0"/>
+                      </p:stCondLst>
+                      <p:childTnLst>
+                        <p:par>
+                          <p:cTn id="3" presetID="10" presetClass="entr" presetSubtype="0" fill="hold" nodeType="withEffect">
+                            <p:stCondLst>
+                              <p:cond delay="0"/>
+                            </p:stCondLst>
+                            <p:childTnLst>
+                              <p:animEffect transition="in" filter="fade">
+                                <p:cBhvr>
+                                  <p:cTn id="4" dur="450"/>
+                                  <p:tgtEl>
+                                    <p:spTgt spid="2"/>
+                                  </p:tgtEl>
+                                </p:cBhvr>
+                              </p:animEffect>
+                            </p:childTnLst>
+                          </p:cTn>
+                        </p:par>
+                        <p:par>
+                          <p:cTn id="5" presetID="10" presetClass="entr" presetSubtype="0" fill="hold" nodeType="withEffect">
+                            <p:stCondLst>
+                              <p:cond delay="200"/>
+                            </p:stCondLst>
+                            <p:childTnLst>
+                              <p:animEffect transition="in" filter="fade">
+                                <p:cBhvr>
+                                  <p:cTn id="6" dur="450"/>
+                                  <p:tgtEl>
+                                    <p:spTgt spid="3"/>
+                                  </p:tgtEl>
+                                </p:cBhvr>
+                              </p:animEffect>
+                            </p:childTnLst>
+                          </p:cTn>
+                        </p:par>
+                        <p:par>
+                          <p:cTn id="7" presetID="10" presetClass="entr" presetSubtype="0" fill="hold" nodeType="withEffect">
+                            <p:stCondLst>
+                              <p:cond delay="200"/>
+                            </p:stCondLst>
+                            <p:childTnLst>
+                              <p:animEffect transition="in" filter="fade">
+                                <p:cBhvr>
+                                  <p:cTn id="8" dur="450"/>
+                                  <p:tgtEl>
+                                    <p:spTgt spid="4"/>
+                                  </p:tgtEl>
+                                </p:cBhvr>
+                              </p:animEffect>
+                            </p:childTnLst>
+                          </p:cTn>
+                        </p:par>
+                      </p:childTnLst>
+                    </p:cTn>
+                  </p:par>
+                </p:childTnLst>
+              </p:cTn>
+              <p:prevCondLst>
+                <p:cond evt="onPrev" delay="0">
+                  <p:tgtEl>
+                    <p:sldTgt/>
+                  </p:tgtEl>
+                </p:cond>
+              </p:prevCondLst>
+              <p:nextCondLst>
+                <p:cond evt="onNext" delay="0">
+                  <p:tgtEl>
+                    <p:sldTgt/>
+                  </p:tgtEl>
+                </p:cond>
+              </p:nextCondLst>
+            </p:seq>
+          </p:childTnLst>
+        </p:cTn>
+      </p:par>
+    </p:tnLst>
+  </p:timing>
 </p:sld>
 </file>
 
@@ -8519,6 +9329,96 @@
   <p:clrMapOvr>
     <a:masterClrMapping/>
   </p:clrMapOvr>
+  <p:timing>
+    <p:tnLst>
+      <p:par>
+        <p:cTn id="1" dur="indefinite" restart="never" nodeType="tmRoot">
+          <p:childTnLst>
+            <p:seq concurrent="true" nextAc="seek">
+              <p:cTn id="2" dur="indefinite" nodeType="mainSeq">
+                <p:childTnLst>
+                  <p:par>
+                    <p:cTn id="9" fill="hold">
+                      <p:stCondLst>
+                        <p:cond delay="0"/>
+                      </p:stCondLst>
+                      <p:childTnLst>
+                        <p:par>
+                          <p:cTn id="3" presetID="10" presetClass="entr" presetSubtype="0" fill="hold" nodeType="withEffect">
+                            <p:stCondLst>
+                              <p:cond delay="0"/>
+                            </p:stCondLst>
+                            <p:childTnLst>
+                              <p:animEffect transition="in" filter="fade">
+                                <p:cBhvr>
+                                  <p:cTn id="4" dur="450"/>
+                                  <p:tgtEl>
+                                    <p:spTgt spid="2"/>
+                                  </p:tgtEl>
+                                </p:cBhvr>
+                              </p:animEffect>
+                            </p:childTnLst>
+                          </p:cTn>
+                        </p:par>
+                        <p:par>
+                          <p:cTn id="5" presetID="10" presetClass="entr" presetSubtype="0" fill="hold" nodeType="withEffect">
+                            <p:stCondLst>
+                              <p:cond delay="200"/>
+                            </p:stCondLst>
+                            <p:childTnLst>
+                              <p:animEffect transition="in" filter="fade">
+                                <p:cBhvr>
+                                  <p:cTn id="6" dur="450"/>
+                                  <p:tgtEl>
+                                    <p:spTgt spid="3"/>
+                                  </p:tgtEl>
+                                </p:cBhvr>
+                              </p:animEffect>
+                            </p:childTnLst>
+                          </p:cTn>
+                        </p:par>
+                        <p:par>
+                          <p:cTn id="7" presetID="10" presetClass="entr" presetSubtype="0" fill="hold" nodeType="withEffect">
+                            <p:stCondLst>
+                              <p:cond delay="200"/>
+                            </p:stCondLst>
+                            <p:childTnLst>
+                              <p:animEffect transition="in" filter="fade">
+                                <p:cBhvr>
+                                  <p:cTn id="8" dur="450"/>
+                                  <p:tgtEl>
+                                    <p:spTgt spid="4"/>
+                                  </p:tgtEl>
+                                </p:cBhvr>
+                              </p:animEffect>
+                            </p:childTnLst>
+                          </p:cTn>
+                        </p:par>
+                      </p:childTnLst>
+                    </p:cTn>
+                  </p:par>
+                </p:childTnLst>
+              </p:cTn>
+              <p:prevCondLst>
+                <p:cond evt="onPrev" delay="0">
+                  <p:tgtEl>
+                    <p:sldTgt/>
+                  </p:tgtEl>
+                </p:cond>
+              </p:prevCondLst>
+              <p:nextCondLst>
+                <p:cond evt="onNext" delay="0">
+                  <p:tgtEl>
+                    <p:sldTgt/>
+                  </p:tgtEl>
+                </p:cond>
+              </p:nextCondLst>
+            </p:seq>
+          </p:childTnLst>
+        </p:cTn>
+      </p:par>
+    </p:tnLst>
+  </p:timing>
 </p:sld>
 </file>
 

</xml_diff>